<commit_message>
fix(ci): fix yaml schema, remove invalid env context in if condition, update keepalive action to v2
</commit_message>
<xml_diff>
--- a/reports/Road_Accident_Severity_Academic_Deck.pptx
+++ b/reports/Road_Accident_Severity_Academic_Deck.pptx
@@ -4309,7 +4309,7 @@
           </a:prstGeom>
           <a:extLst>
             <a:ext uri="{C572A759-6A51-4108-AA02-DFA0A04FC94B}">
-              <ma14:wrappingTextBoxFlag xmlns:ma14="http://schemas.microsoft.com/office/mac/drawingml/2011/main" xmlns="" val="0"/>
+              <ma14:wrappingTextBoxFlag xmlns="" xmlns:ma14="http://schemas.microsoft.com/office/mac/drawingml/2011/main" val="0"/>
             </a:ext>
           </a:extLst>
         </p:spPr>
@@ -4429,7 +4429,7 @@
           </a:prstGeom>
           <a:extLst>
             <a:ext uri="{C572A759-6A51-4108-AA02-DFA0A04FC94B}">
-              <ma14:wrappingTextBoxFlag xmlns:ma14="http://schemas.microsoft.com/office/mac/drawingml/2011/main" xmlns="" val="0"/>
+              <ma14:wrappingTextBoxFlag xmlns="" xmlns:ma14="http://schemas.microsoft.com/office/mac/drawingml/2011/main" val="0"/>
             </a:ext>
           </a:extLst>
         </p:spPr>
@@ -4507,7 +4507,7 @@
           </a:prstGeom>
           <a:extLst>
             <a:ext uri="{C572A759-6A51-4108-AA02-DFA0A04FC94B}">
-              <ma14:wrappingTextBoxFlag xmlns:ma14="http://schemas.microsoft.com/office/mac/drawingml/2011/main" xmlns="" val="0"/>
+              <ma14:wrappingTextBoxFlag xmlns="" xmlns:ma14="http://schemas.microsoft.com/office/mac/drawingml/2011/main" val="0"/>
             </a:ext>
           </a:extLst>
         </p:spPr>
@@ -5186,7 +5186,7 @@
           </a:prstGeom>
           <a:extLst>
             <a:ext uri="{C572A759-6A51-4108-AA02-DFA0A04FC94B}">
-              <ma14:wrappingTextBoxFlag xmlns:ma14="http://schemas.microsoft.com/office/mac/drawingml/2011/main" xmlns="" val="0"/>
+              <ma14:wrappingTextBoxFlag xmlns="" xmlns:ma14="http://schemas.microsoft.com/office/mac/drawingml/2011/main" val="0"/>
             </a:ext>
           </a:extLst>
         </p:spPr>
@@ -7740,7 +7740,7 @@
           </a:prstGeom>
           <a:extLst>
             <a:ext uri="{C572A759-6A51-4108-AA02-DFA0A04FC94B}">
-              <ma14:wrappingTextBoxFlag xmlns:ma14="http://schemas.microsoft.com/office/mac/drawingml/2011/main" xmlns="" val="0"/>
+              <ma14:wrappingTextBoxFlag xmlns="" xmlns:ma14="http://schemas.microsoft.com/office/mac/drawingml/2011/main" val="0"/>
             </a:ext>
           </a:extLst>
         </p:spPr>
@@ -10296,7 +10296,7 @@
           </a:prstGeom>
           <a:extLst>
             <a:ext uri="{C572A759-6A51-4108-AA02-DFA0A04FC94B}">
-              <ma14:wrappingTextBoxFlag xmlns:ma14="http://schemas.microsoft.com/office/mac/drawingml/2011/main" xmlns="" val="0"/>
+              <ma14:wrappingTextBoxFlag xmlns="" xmlns:ma14="http://schemas.microsoft.com/office/mac/drawingml/2011/main" val="0"/>
             </a:ext>
           </a:extLst>
         </p:spPr>
@@ -10975,7 +10975,7 @@
           </a:prstGeom>
           <a:extLst>
             <a:ext uri="{C572A759-6A51-4108-AA02-DFA0A04FC94B}">
-              <ma14:wrappingTextBoxFlag xmlns:ma14="http://schemas.microsoft.com/office/mac/drawingml/2011/main" xmlns="" val="0"/>
+              <ma14:wrappingTextBoxFlag xmlns="" xmlns:ma14="http://schemas.microsoft.com/office/mac/drawingml/2011/main" val="0"/>
             </a:ext>
           </a:extLst>
         </p:spPr>
@@ -12380,7 +12380,7 @@
           </a:prstGeom>
           <a:extLst>
             <a:ext uri="{C572A759-6A51-4108-AA02-DFA0A04FC94B}">
-              <ma14:wrappingTextBoxFlag xmlns:ma14="http://schemas.microsoft.com/office/mac/drawingml/2011/main" xmlns="" val="0"/>
+              <ma14:wrappingTextBoxFlag xmlns="" xmlns:ma14="http://schemas.microsoft.com/office/mac/drawingml/2011/main" val="0"/>
             </a:ext>
           </a:extLst>
         </p:spPr>
@@ -13316,7 +13316,7 @@
           </a:prstGeom>
           <a:extLst>
             <a:ext uri="{C572A759-6A51-4108-AA02-DFA0A04FC94B}">
-              <ma14:wrappingTextBoxFlag xmlns:ma14="http://schemas.microsoft.com/office/mac/drawingml/2011/main" xmlns="" val="0"/>
+              <ma14:wrappingTextBoxFlag xmlns="" xmlns:ma14="http://schemas.microsoft.com/office/mac/drawingml/2011/main" val="0"/>
             </a:ext>
           </a:extLst>
         </p:spPr>
@@ -15314,7 +15314,7 @@
           </a:prstGeom>
           <a:extLst>
             <a:ext uri="{C572A759-6A51-4108-AA02-DFA0A04FC94B}">
-              <ma14:wrappingTextBoxFlag xmlns:ma14="http://schemas.microsoft.com/office/mac/drawingml/2011/main" xmlns="" val="0"/>
+              <ma14:wrappingTextBoxFlag xmlns="" xmlns:ma14="http://schemas.microsoft.com/office/mac/drawingml/2011/main" val="0"/>
             </a:ext>
           </a:extLst>
         </p:spPr>
@@ -16190,7 +16190,7 @@
           </a:prstGeom>
           <a:extLst>
             <a:ext uri="{C572A759-6A51-4108-AA02-DFA0A04FC94B}">
-              <ma14:wrappingTextBoxFlag xmlns:ma14="http://schemas.microsoft.com/office/mac/drawingml/2011/main" xmlns="" val="0"/>
+              <ma14:wrappingTextBoxFlag xmlns="" xmlns:ma14="http://schemas.microsoft.com/office/mac/drawingml/2011/main" val="0"/>
             </a:ext>
           </a:extLst>
         </p:spPr>
@@ -17068,7 +17068,7 @@
           </a:prstGeom>
           <a:extLst>
             <a:ext uri="{C572A759-6A51-4108-AA02-DFA0A04FC94B}">
-              <ma14:wrappingTextBoxFlag xmlns:ma14="http://schemas.microsoft.com/office/mac/drawingml/2011/main" xmlns="" val="0"/>
+              <ma14:wrappingTextBoxFlag xmlns="" xmlns:ma14="http://schemas.microsoft.com/office/mac/drawingml/2011/main" val="0"/>
             </a:ext>
           </a:extLst>
         </p:spPr>
@@ -19064,7 +19064,7 @@
           </a:prstGeom>
           <a:extLst>
             <a:ext uri="{C572A759-6A51-4108-AA02-DFA0A04FC94B}">
-              <ma14:wrappingTextBoxFlag xmlns:ma14="http://schemas.microsoft.com/office/mac/drawingml/2011/main" xmlns="" val="0"/>
+              <ma14:wrappingTextBoxFlag xmlns="" xmlns:ma14="http://schemas.microsoft.com/office/mac/drawingml/2011/main" val="0"/>
             </a:ext>
           </a:extLst>
         </p:spPr>
@@ -20708,7 +20708,7 @@
           </a:prstGeom>
           <a:extLst>
             <a:ext uri="{C572A759-6A51-4108-AA02-DFA0A04FC94B}">
-              <ma14:wrappingTextBoxFlag xmlns:ma14="http://schemas.microsoft.com/office/mac/drawingml/2011/main" xmlns="" val="0"/>
+              <ma14:wrappingTextBoxFlag xmlns="" xmlns:ma14="http://schemas.microsoft.com/office/mac/drawingml/2011/main" val="0"/>
             </a:ext>
           </a:extLst>
         </p:spPr>
@@ -22602,7 +22602,7 @@
           </a:prstGeom>
           <a:extLst>
             <a:ext uri="{C572A759-6A51-4108-AA02-DFA0A04FC94B}">
-              <ma14:wrappingTextBoxFlag xmlns:ma14="http://schemas.microsoft.com/office/mac/drawingml/2011/main" xmlns="" val="0"/>
+              <ma14:wrappingTextBoxFlag xmlns="" xmlns:ma14="http://schemas.microsoft.com/office/mac/drawingml/2011/main" val="0"/>
             </a:ext>
           </a:extLst>
         </p:spPr>
@@ -24614,7 +24614,7 @@
           </a:prstGeom>
           <a:extLst>
             <a:ext uri="{C572A759-6A51-4108-AA02-DFA0A04FC94B}">
-              <ma14:wrappingTextBoxFlag xmlns:ma14="http://schemas.microsoft.com/office/mac/drawingml/2011/main" xmlns="" val="0"/>
+              <ma14:wrappingTextBoxFlag xmlns="" xmlns:ma14="http://schemas.microsoft.com/office/mac/drawingml/2011/main" val="0"/>
             </a:ext>
           </a:extLst>
         </p:spPr>
@@ -25156,7 +25156,7 @@
           </a:prstGeom>
           <a:extLst>
             <a:ext uri="{C572A759-6A51-4108-AA02-DFA0A04FC94B}">
-              <ma14:wrappingTextBoxFlag xmlns:ma14="http://schemas.microsoft.com/office/mac/drawingml/2011/main" xmlns="" val="0"/>
+              <ma14:wrappingTextBoxFlag xmlns="" xmlns:ma14="http://schemas.microsoft.com/office/mac/drawingml/2011/main" val="0"/>
             </a:ext>
           </a:extLst>
         </p:spPr>
@@ -27542,7 +27542,7 @@
           </a:prstGeom>
           <a:extLst>
             <a:ext uri="{C572A759-6A51-4108-AA02-DFA0A04FC94B}">
-              <ma14:wrappingTextBoxFlag xmlns:ma14="http://schemas.microsoft.com/office/mac/drawingml/2011/main" xmlns="" val="0"/>
+              <ma14:wrappingTextBoxFlag xmlns="" xmlns:ma14="http://schemas.microsoft.com/office/mac/drawingml/2011/main" val="0"/>
             </a:ext>
           </a:extLst>
         </p:spPr>
@@ -28440,7 +28440,7 @@
           </a:prstGeom>
           <a:extLst>
             <a:ext uri="{C572A759-6A51-4108-AA02-DFA0A04FC94B}">
-              <ma14:wrappingTextBoxFlag xmlns:ma14="http://schemas.microsoft.com/office/mac/drawingml/2011/main" xmlns="" val="0"/>
+              <ma14:wrappingTextBoxFlag xmlns="" xmlns:ma14="http://schemas.microsoft.com/office/mac/drawingml/2011/main" val="0"/>
             </a:ext>
           </a:extLst>
         </p:spPr>
@@ -29740,7 +29740,7 @@
           </a:prstGeom>
           <a:extLst>
             <a:ext uri="{C572A759-6A51-4108-AA02-DFA0A04FC94B}">
-              <ma14:wrappingTextBoxFlag xmlns:ma14="http://schemas.microsoft.com/office/mac/drawingml/2011/main" xmlns="" val="0"/>
+              <ma14:wrappingTextBoxFlag xmlns="" xmlns:ma14="http://schemas.microsoft.com/office/mac/drawingml/2011/main" val="0"/>
             </a:ext>
           </a:extLst>
         </p:spPr>
@@ -30211,7 +30211,7 @@
           </a:prstGeom>
           <a:extLst>
             <a:ext uri="{C572A759-6A51-4108-AA02-DFA0A04FC94B}">
-              <ma14:wrappingTextBoxFlag xmlns:ma14="http://schemas.microsoft.com/office/mac/drawingml/2011/main" xmlns="" val="0"/>
+              <ma14:wrappingTextBoxFlag xmlns="" xmlns:ma14="http://schemas.microsoft.com/office/mac/drawingml/2011/main" val="0"/>
             </a:ext>
           </a:extLst>
         </p:spPr>
@@ -31782,7 +31782,7 @@
           </a:prstGeom>
           <a:extLst>
             <a:ext uri="{C572A759-6A51-4108-AA02-DFA0A04FC94B}">
-              <ma14:wrappingTextBoxFlag xmlns:ma14="http://schemas.microsoft.com/office/mac/drawingml/2011/main" xmlns="" val="0"/>
+              <ma14:wrappingTextBoxFlag xmlns="" xmlns:ma14="http://schemas.microsoft.com/office/mac/drawingml/2011/main" val="0"/>
             </a:ext>
           </a:extLst>
         </p:spPr>
@@ -35408,7 +35408,7 @@
           </a:prstGeom>
           <a:extLst>
             <a:ext uri="{C572A759-6A51-4108-AA02-DFA0A04FC94B}">
-              <ma14:wrappingTextBoxFlag xmlns:ma14="http://schemas.microsoft.com/office/mac/drawingml/2011/main" xmlns="" val="0"/>
+              <ma14:wrappingTextBoxFlag xmlns="" xmlns:ma14="http://schemas.microsoft.com/office/mac/drawingml/2011/main" val="0"/>
             </a:ext>
           </a:extLst>
         </p:spPr>
@@ -36050,7 +36050,7 @@
           </a:prstGeom>
           <a:extLst>
             <a:ext uri="{C572A759-6A51-4108-AA02-DFA0A04FC94B}">
-              <ma14:wrappingTextBoxFlag xmlns:ma14="http://schemas.microsoft.com/office/mac/drawingml/2011/main" xmlns="" val="0"/>
+              <ma14:wrappingTextBoxFlag xmlns="" xmlns:ma14="http://schemas.microsoft.com/office/mac/drawingml/2011/main" val="0"/>
             </a:ext>
           </a:extLst>
         </p:spPr>
@@ -37330,7 +37330,7 @@
           </a:prstGeom>
           <a:extLst>
             <a:ext uri="{C572A759-6A51-4108-AA02-DFA0A04FC94B}">
-              <ma14:wrappingTextBoxFlag xmlns:ma14="http://schemas.microsoft.com/office/mac/drawingml/2011/main" xmlns="" val="0"/>
+              <ma14:wrappingTextBoxFlag xmlns="" xmlns:ma14="http://schemas.microsoft.com/office/mac/drawingml/2011/main" val="0"/>
             </a:ext>
           </a:extLst>
         </p:spPr>
@@ -39457,7 +39457,7 @@
           </a:prstGeom>
           <a:extLst>
             <a:ext uri="{C572A759-6A51-4108-AA02-DFA0A04FC94B}">
-              <ma14:wrappingTextBoxFlag xmlns:ma14="http://schemas.microsoft.com/office/mac/drawingml/2011/main" xmlns="" val="0"/>
+              <ma14:wrappingTextBoxFlag xmlns="" xmlns:ma14="http://schemas.microsoft.com/office/mac/drawingml/2011/main" val="0"/>
             </a:ext>
           </a:extLst>
         </p:spPr>
@@ -41561,7 +41561,7 @@
           </a:prstGeom>
           <a:extLst>
             <a:ext uri="{C572A759-6A51-4108-AA02-DFA0A04FC94B}">
-              <ma14:wrappingTextBoxFlag xmlns:ma14="http://schemas.microsoft.com/office/mac/drawingml/2011/main" xmlns="" val="0"/>
+              <ma14:wrappingTextBoxFlag xmlns="" xmlns:ma14="http://schemas.microsoft.com/office/mac/drawingml/2011/main" val="0"/>
             </a:ext>
           </a:extLst>
         </p:spPr>

</xml_diff>